<commit_message>
feat(colab): Push a code into git after Learning data preparation part.
</commit_message>
<xml_diff>
--- a/data-science.pptx
+++ b/data-science.pptx
@@ -9666,6 +9666,47 @@
           </a:effectLst>
         </p:spPr>
       </p:pic>
+      <p:sp>
+        <p:nvSpPr>
+          <p:cNvPr id="3" name="TextBox 2">
+            <a:extLst>
+              <a:ext uri="{FF2B5EF4-FFF2-40B4-BE49-F238E27FC236}">
+                <a16:creationId xmlns:a16="http://schemas.microsoft.com/office/drawing/2014/main" id="{A8CD694F-A91B-400D-0BDB-76A3D7E8664D}"/>
+              </a:ext>
+            </a:extLst>
+          </p:cNvPr>
+          <p:cNvSpPr txBox="1"/>
+          <p:nvPr/>
+        </p:nvSpPr>
+        <p:spPr>
+          <a:xfrm>
+            <a:off x="1317523" y="1465623"/>
+            <a:ext cx="9556954" cy="338554"/>
+          </a:xfrm>
+          <a:prstGeom prst="rect">
+            <a:avLst/>
+          </a:prstGeom>
+          <a:noFill/>
+        </p:spPr>
+        <p:txBody>
+          <a:bodyPr wrap="square" rtlCol="0">
+            <a:spAutoFit/>
+          </a:bodyPr>
+          <a:lstStyle/>
+          <a:p>
+            <a:r>
+              <a:rPr lang="en-US" sz="1600" dirty="0">
+                <a:solidFill>
+                  <a:srgbClr val="FF0000"/>
+                </a:solidFill>
+                <a:latin typeface="Anuphan" pitchFamily="2" charset="-34"/>
+                <a:cs typeface="Anuphan" pitchFamily="2" charset="-34"/>
+              </a:rPr>
+              <a:t>** X shape should be 8 columns. **</a:t>
+            </a:r>
+          </a:p>
+        </p:txBody>
+      </p:sp>
     </p:spTree>
     <p:extLst>
       <p:ext uri="{BB962C8B-B14F-4D97-AF65-F5344CB8AC3E}">

</xml_diff>